<commit_message>
lecture ready(0806) : filter, ref, lifecycle
</commit_message>
<xml_diff>
--- a/material/[SeSAC_YDP_6] 26_React_map_filter.pptx
+++ b/material/[SeSAC_YDP_6] 26_React_map_filter.pptx
@@ -5,7 +5,7 @@
     <p:sldMasterId id="2147483686" r:id="rId1"/>
   </p:sldMasterIdLst>
   <p:notesMasterIdLst>
-    <p:notesMasterId r:id="rId20"/>
+    <p:notesMasterId r:id="rId18"/>
   </p:notesMasterIdLst>
   <p:sldIdLst>
     <p:sldId id="256" r:id="rId2"/>
@@ -18,14 +18,12 @@
     <p:sldId id="277" r:id="rId9"/>
     <p:sldId id="278" r:id="rId10"/>
     <p:sldId id="279" r:id="rId11"/>
-    <p:sldId id="280" r:id="rId12"/>
-    <p:sldId id="290" r:id="rId13"/>
-    <p:sldId id="282" r:id="rId14"/>
-    <p:sldId id="283" r:id="rId15"/>
-    <p:sldId id="284" r:id="rId16"/>
-    <p:sldId id="285" r:id="rId17"/>
-    <p:sldId id="286" r:id="rId18"/>
-    <p:sldId id="293" r:id="rId19"/>
+    <p:sldId id="290" r:id="rId12"/>
+    <p:sldId id="282" r:id="rId13"/>
+    <p:sldId id="283" r:id="rId14"/>
+    <p:sldId id="284" r:id="rId15"/>
+    <p:sldId id="285" r:id="rId16"/>
+    <p:sldId id="293" r:id="rId17"/>
   </p:sldIdLst>
   <p:sldSz cx="12192000" cy="6858000"/>
   <p:notesSz cx="6858000" cy="9144000"/>
@@ -217,7 +215,7 @@
           <a:p>
             <a:fld id="{2EF3F159-7250-4DD4-91C2-13B35D56E1AF}" type="datetimeFigureOut">
               <a:rPr lang="ko-KR" altLang="en-US" smtClean="0"/>
-              <a:t>2024-08-05</a:t>
+              <a:t>2024-08-06</a:t>
             </a:fld>
             <a:endParaRPr lang="ko-KR" altLang="en-US"/>
           </a:p>
@@ -612,6 +610,10 @@
           <a:bodyPr/>
           <a:lstStyle/>
           <a:p>
+            <a:r>
+              <a:rPr lang="en-US" altLang="ko-KR" dirty="0"/>
+              <a:t> </a:t>
+            </a:r>
             <a:endParaRPr lang="ko-KR" altLang="en-US" dirty="0"/>
           </a:p>
         </p:txBody>
@@ -642,7 +644,7 @@
     </p:spTree>
     <p:extLst>
       <p:ext uri="{BB962C8B-B14F-4D97-AF65-F5344CB8AC3E}">
-        <p14:creationId xmlns:p14="http://schemas.microsoft.com/office/powerpoint/2010/main" val="4174695049"/>
+        <p14:creationId xmlns:p14="http://schemas.microsoft.com/office/powerpoint/2010/main" val="1328778394"/>
       </p:ext>
     </p:extLst>
   </p:cSld>
@@ -696,6 +698,23 @@
           <a:bodyPr/>
           <a:lstStyle/>
           <a:p>
+            <a:r>
+              <a:rPr lang="ko-KR" altLang="en-US" dirty="0"/>
+              <a:t>배열의　각　요소를　주어진　조건에　따라　평가한　후，　그　조건을　만족하는　요소만을　새로운　배열로　반환함．</a:t>
+            </a:r>
+            <a:endParaRPr lang="en-US" altLang="ko-KR" dirty="0"/>
+          </a:p>
+          <a:p>
+            <a:r>
+              <a:rPr lang="ko-KR" altLang="en-US" dirty="0"/>
+              <a:t>이　또한　역시，　원본　배열을　변경하지　않음．</a:t>
+            </a:r>
+            <a:endParaRPr lang="en-US" altLang="ko-KR" dirty="0"/>
+          </a:p>
+          <a:p>
+            <a:endParaRPr lang="en-US" altLang="ko-KR" dirty="0"/>
+          </a:p>
+          <a:p>
             <a:endParaRPr lang="ko-KR" altLang="en-US" dirty="0"/>
           </a:p>
         </p:txBody>
@@ -717,7 +736,7 @@
           <a:p>
             <a:fld id="{C09E5BFC-1559-42F1-8940-AB342D56BF02}" type="slidenum">
               <a:rPr lang="ko-KR" altLang="en-US" smtClean="0"/>
-              <a:t>16</a:t>
+              <a:t>12</a:t>
             </a:fld>
             <a:endParaRPr lang="ko-KR" altLang="en-US"/>
           </a:p>
@@ -726,7 +745,7 @@
     </p:spTree>
     <p:extLst>
       <p:ext uri="{BB962C8B-B14F-4D97-AF65-F5344CB8AC3E}">
-        <p14:creationId xmlns:p14="http://schemas.microsoft.com/office/powerpoint/2010/main" val="2752525777"/>
+        <p14:creationId xmlns:p14="http://schemas.microsoft.com/office/powerpoint/2010/main" val="2243902190"/>
       </p:ext>
     </p:extLst>
   </p:cSld>
@@ -780,22 +799,6 @@
           <a:bodyPr/>
           <a:lstStyle/>
           <a:p>
-            <a:r>
-              <a:rPr lang="en-US" altLang="ko-KR" dirty="0"/>
-              <a:t>Reduce</a:t>
-            </a:r>
-            <a:r>
-              <a:rPr lang="en-US" altLang="ko-KR" baseline="0" dirty="0"/>
-              <a:t> </a:t>
-            </a:r>
-            <a:r>
-              <a:rPr lang="ko-KR" altLang="en-US" baseline="0" dirty="0"/>
-              <a:t>함수 설명도 추가 가능하다면</a:t>
-            </a:r>
-            <a:r>
-              <a:rPr lang="en-US" altLang="ko-KR" baseline="0"/>
-              <a:t>! </a:t>
-            </a:r>
             <a:endParaRPr lang="ko-KR" altLang="en-US" dirty="0"/>
           </a:p>
         </p:txBody>
@@ -817,7 +820,7 @@
           <a:p>
             <a:fld id="{C09E5BFC-1559-42F1-8940-AB342D56BF02}" type="slidenum">
               <a:rPr lang="ko-KR" altLang="en-US" smtClean="0"/>
-              <a:t>17</a:t>
+              <a:t>15</a:t>
             </a:fld>
             <a:endParaRPr lang="ko-KR" altLang="en-US"/>
           </a:p>
@@ -826,7 +829,7 @@
     </p:spTree>
     <p:extLst>
       <p:ext uri="{BB962C8B-B14F-4D97-AF65-F5344CB8AC3E}">
-        <p14:creationId xmlns:p14="http://schemas.microsoft.com/office/powerpoint/2010/main" val="2839057405"/>
+        <p14:creationId xmlns:p14="http://schemas.microsoft.com/office/powerpoint/2010/main" val="2752525777"/>
       </p:ext>
     </p:extLst>
   </p:cSld>
@@ -901,7 +904,7 @@
           <a:p>
             <a:fld id="{C09E5BFC-1559-42F1-8940-AB342D56BF02}" type="slidenum">
               <a:rPr lang="ko-KR" altLang="en-US" smtClean="0"/>
-              <a:t>18</a:t>
+              <a:t>16</a:t>
             </a:fld>
             <a:endParaRPr lang="ko-KR" altLang="en-US"/>
           </a:p>
@@ -6143,50 +6146,7 @@
       </p:grpSpPr>
       <p:sp>
         <p:nvSpPr>
-          <p:cNvPr id="3" name="내용 개체 틀 2">
-            <a:extLst>
-              <a:ext uri="{FF2B5EF4-FFF2-40B4-BE49-F238E27FC236}">
-                <a16:creationId xmlns:a16="http://schemas.microsoft.com/office/drawing/2014/main" id="{43B6E6F2-4A1F-0E69-67A4-8E7EA1060480}"/>
-              </a:ext>
-            </a:extLst>
-          </p:cNvPr>
-          <p:cNvSpPr>
-            <a:spLocks noGrp="1"/>
-          </p:cNvSpPr>
-          <p:nvPr>
-            <p:ph idx="1"/>
-          </p:nvPr>
-        </p:nvSpPr>
-        <p:spPr>
-          <a:xfrm>
-            <a:off x="838200" y="1215483"/>
-            <a:ext cx="10515600" cy="4461417"/>
-          </a:xfrm>
-        </p:spPr>
-        <p:txBody>
-          <a:bodyPr/>
-          <a:lstStyle/>
-          <a:p>
-            <a:r>
-              <a:rPr lang="en-US" altLang="ko-KR" dirty="0"/>
-              <a:t>input</a:t>
-            </a:r>
-            <a:r>
-              <a:rPr lang="ko-KR" altLang="en-US" dirty="0"/>
-              <a:t>으로 새로운 알파벳 추가해보기</a:t>
-            </a:r>
-          </a:p>
-        </p:txBody>
-      </p:sp>
-      <p:sp>
-        <p:nvSpPr>
-          <p:cNvPr id="4" name="날짜 개체 틀 3">
-            <a:extLst>
-              <a:ext uri="{FF2B5EF4-FFF2-40B4-BE49-F238E27FC236}">
-                <a16:creationId xmlns:a16="http://schemas.microsoft.com/office/drawing/2014/main" id="{8F058E69-2519-5C7B-E619-FCE4F8E785F7}"/>
-              </a:ext>
-            </a:extLst>
-          </p:cNvPr>
+          <p:cNvPr id="2" name="날짜 개체 틀 1"/>
           <p:cNvSpPr>
             <a:spLocks noGrp="1"/>
           </p:cNvSpPr>
@@ -6199,7 +6159,7 @@
           <a:bodyPr/>
           <a:lstStyle/>
           <a:p>
-            <a:fld id="{499F60AA-9663-4C10-96A7-DFE487A1DFF7}" type="datetime6">
+            <a:fld id="{0E19CB95-6D28-40F1-9DA3-1BAC5D4B5B4F}" type="datetime6">
               <a:rPr lang="ko-KR" altLang="en-US" smtClean="0"/>
               <a:t>2024년 8월</a:t>
             </a:fld>
@@ -6209,13 +6169,7 @@
       </p:sp>
       <p:sp>
         <p:nvSpPr>
-          <p:cNvPr id="5" name="슬라이드 번호 개체 틀 4">
-            <a:extLst>
-              <a:ext uri="{FF2B5EF4-FFF2-40B4-BE49-F238E27FC236}">
-                <a16:creationId xmlns:a16="http://schemas.microsoft.com/office/drawing/2014/main" id="{4A2D925E-B075-9DDE-125B-43171B9E6A97}"/>
-              </a:ext>
-            </a:extLst>
-          </p:cNvPr>
+          <p:cNvPr id="3" name="슬라이드 번호 개체 틀 2"/>
           <p:cNvSpPr>
             <a:spLocks noGrp="1"/>
           </p:cNvSpPr>
@@ -6238,13 +6192,7 @@
       </p:sp>
       <p:sp>
         <p:nvSpPr>
-          <p:cNvPr id="2" name="제목 1">
-            <a:extLst>
-              <a:ext uri="{FF2B5EF4-FFF2-40B4-BE49-F238E27FC236}">
-                <a16:creationId xmlns:a16="http://schemas.microsoft.com/office/drawing/2014/main" id="{DEEAE432-154C-1C3F-A5EC-16DFF73F5EC7}"/>
-              </a:ext>
-            </a:extLst>
-          </p:cNvPr>
+          <p:cNvPr id="4" name="제목 3"/>
           <p:cNvSpPr>
             <a:spLocks noGrp="1"/>
           </p:cNvSpPr>
@@ -6258,58 +6206,25 @@
           <a:lstStyle/>
           <a:p>
             <a:r>
-              <a:rPr lang="en-US" altLang="ko-KR" dirty="0"/>
-              <a:t>Component</a:t>
-            </a:r>
-            <a:r>
-              <a:rPr lang="ko-KR" altLang="en-US" dirty="0"/>
-              <a:t>에 </a:t>
-            </a:r>
-            <a:r>
-              <a:rPr lang="en-US" altLang="ko-KR" dirty="0"/>
-              <a:t>map() </a:t>
-            </a:r>
-            <a:r>
-              <a:rPr lang="ko-KR" altLang="en-US" dirty="0"/>
-              <a:t>적용</a:t>
-            </a:r>
-          </a:p>
-        </p:txBody>
-      </p:sp>
-      <p:pic>
-        <p:nvPicPr>
-          <p:cNvPr id="10" name="그림 9">
-            <a:extLst>
-              <a:ext uri="{FF2B5EF4-FFF2-40B4-BE49-F238E27FC236}">
-                <a16:creationId xmlns:a16="http://schemas.microsoft.com/office/drawing/2014/main" id="{36B95769-FA4E-C4E3-980B-0857B1994508}"/>
-              </a:ext>
-            </a:extLst>
-          </p:cNvPr>
-          <p:cNvPicPr>
-            <a:picLocks noChangeAspect="1"/>
-          </p:cNvPicPr>
-          <p:nvPr/>
-        </p:nvPicPr>
-        <p:blipFill>
-          <a:blip r:embed="rId3"/>
-          <a:stretch>
-            <a:fillRect/>
-          </a:stretch>
-        </p:blipFill>
-        <p:spPr>
-          <a:xfrm>
-            <a:off x="1119592" y="1897380"/>
-            <a:ext cx="9085897" cy="4366523"/>
-          </a:xfrm>
-          <a:prstGeom prst="rect">
-            <a:avLst/>
-          </a:prstGeom>
-        </p:spPr>
-      </p:pic>
+              <a:rPr lang="en-US" altLang="ko-KR" sz="7200" dirty="0"/>
+              <a:t>filter()</a:t>
+            </a:r>
+            <a:r>
+              <a:rPr lang="ko-KR" altLang="en-US" sz="7200" dirty="0"/>
+              <a:t>를 이용한 </a:t>
+            </a:r>
+            <a:r>
+              <a:rPr lang="ko-KR" altLang="en-US" sz="7200" dirty="0" err="1"/>
+              <a:t>필터링</a:t>
+            </a:r>
+            <a:endParaRPr lang="ko-KR" altLang="en-US" sz="7200" dirty="0"/>
+          </a:p>
+        </p:txBody>
+      </p:sp>
     </p:spTree>
     <p:extLst>
       <p:ext uri="{BB962C8B-B14F-4D97-AF65-F5344CB8AC3E}">
-        <p14:creationId xmlns:p14="http://schemas.microsoft.com/office/powerpoint/2010/main" val="2025476529"/>
+        <p14:creationId xmlns:p14="http://schemas.microsoft.com/office/powerpoint/2010/main" val="960713128"/>
       </p:ext>
     </p:extLst>
   </p:cSld>
@@ -6338,7 +6253,127 @@
       </p:grpSpPr>
       <p:sp>
         <p:nvSpPr>
-          <p:cNvPr id="2" name="날짜 개체 틀 1"/>
+          <p:cNvPr id="3" name="내용 개체 틀 2">
+            <a:extLst>
+              <a:ext uri="{FF2B5EF4-FFF2-40B4-BE49-F238E27FC236}">
+                <a16:creationId xmlns:a16="http://schemas.microsoft.com/office/drawing/2014/main" id="{FFB0A8FF-58B4-AADA-C277-115F024B2E5A}"/>
+              </a:ext>
+            </a:extLst>
+          </p:cNvPr>
+          <p:cNvSpPr>
+            <a:spLocks noGrp="1"/>
+          </p:cNvSpPr>
+          <p:nvPr>
+            <p:ph idx="1"/>
+          </p:nvPr>
+        </p:nvSpPr>
+        <p:spPr>
+          <a:xfrm>
+            <a:off x="571500" y="1488141"/>
+            <a:ext cx="11049000" cy="4553128"/>
+          </a:xfrm>
+        </p:spPr>
+        <p:txBody>
+          <a:bodyPr/>
+          <a:lstStyle/>
+          <a:p>
+            <a:r>
+              <a:rPr lang="en-US" altLang="ko-KR" dirty="0"/>
+              <a:t>filter()</a:t>
+            </a:r>
+            <a:r>
+              <a:rPr lang="ko-KR" altLang="en-US" dirty="0"/>
+              <a:t>의 인자로 넘겨지는 </a:t>
+            </a:r>
+            <a:r>
+              <a:rPr lang="en-US" altLang="ko-KR" dirty="0"/>
+              <a:t>callback </a:t>
+            </a:r>
+            <a:r>
+              <a:rPr lang="ko-KR" altLang="en-US" dirty="0"/>
+              <a:t>함수의 </a:t>
+            </a:r>
+            <a:r>
+              <a:rPr lang="ko-KR" altLang="en-US" dirty="0">
+                <a:solidFill>
+                  <a:schemeClr val="accent1"/>
+                </a:solidFill>
+              </a:rPr>
+              <a:t>테스트</a:t>
+            </a:r>
+            <a:r>
+              <a:rPr lang="en-US" altLang="ko-KR" dirty="0">
+                <a:solidFill>
+                  <a:schemeClr val="accent1"/>
+                </a:solidFill>
+              </a:rPr>
+              <a:t>(</a:t>
+            </a:r>
+            <a:r>
+              <a:rPr lang="ko-KR" altLang="en-US" dirty="0">
+                <a:solidFill>
+                  <a:schemeClr val="accent1"/>
+                </a:solidFill>
+              </a:rPr>
+              <a:t>조건</a:t>
+            </a:r>
+            <a:r>
+              <a:rPr lang="en-US" altLang="ko-KR" dirty="0">
+                <a:solidFill>
+                  <a:schemeClr val="accent1"/>
+                </a:solidFill>
+              </a:rPr>
+              <a:t>)</a:t>
+            </a:r>
+            <a:r>
+              <a:rPr lang="ko-KR" altLang="en-US" dirty="0">
+                <a:solidFill>
+                  <a:schemeClr val="accent1"/>
+                </a:solidFill>
+              </a:rPr>
+              <a:t>를 통과하는 요소</a:t>
+            </a:r>
+            <a:r>
+              <a:rPr lang="ko-KR" altLang="en-US" dirty="0"/>
+              <a:t>를 모아 새로운 배열을 생성</a:t>
+            </a:r>
+            <a:r>
+              <a:rPr lang="en-US" altLang="ko-KR" dirty="0"/>
+              <a:t>. </a:t>
+            </a:r>
+          </a:p>
+          <a:p>
+            <a:r>
+              <a:rPr lang="en-US" altLang="ko-KR" dirty="0"/>
+              <a:t>filter() </a:t>
+            </a:r>
+            <a:r>
+              <a:rPr lang="ko-KR" altLang="en-US" dirty="0"/>
+              <a:t>함수를 사용하여 배열에서 원하는 값을 삭제하는 코드 구현 가능</a:t>
+            </a:r>
+            <a:r>
+              <a:rPr lang="en-US" altLang="ko-KR" dirty="0"/>
+              <a:t>.</a:t>
+            </a:r>
+            <a:endParaRPr lang="en-US" altLang="ko-KR" sz="4000" dirty="0"/>
+          </a:p>
+          <a:p>
+            <a:pPr marL="0" indent="0">
+              <a:buNone/>
+            </a:pPr>
+            <a:endParaRPr lang="en-US" altLang="ko-KR" sz="4000" dirty="0"/>
+          </a:p>
+        </p:txBody>
+      </p:sp>
+      <p:sp>
+        <p:nvSpPr>
+          <p:cNvPr id="4" name="날짜 개체 틀 3">
+            <a:extLst>
+              <a:ext uri="{FF2B5EF4-FFF2-40B4-BE49-F238E27FC236}">
+                <a16:creationId xmlns:a16="http://schemas.microsoft.com/office/drawing/2014/main" id="{AD912659-0178-7724-84E7-F9804EEB516A}"/>
+              </a:ext>
+            </a:extLst>
+          </p:cNvPr>
           <p:cNvSpPr>
             <a:spLocks noGrp="1"/>
           </p:cNvSpPr>
@@ -6351,17 +6386,23 @@
           <a:bodyPr/>
           <a:lstStyle/>
           <a:p>
-            <a:fld id="{0E19CB95-6D28-40F1-9DA3-1BAC5D4B5B4F}" type="datetime6">
+            <a:fld id="{ECE2EEAA-2D64-41F3-9CC6-1D2C9158BEA1}" type="datetime6">
               <a:rPr lang="ko-KR" altLang="en-US" smtClean="0"/>
               <a:t>2024년 8월</a:t>
             </a:fld>
-            <a:endParaRPr lang="ko-KR" altLang="en-US"/>
-          </a:p>
-        </p:txBody>
-      </p:sp>
-      <p:sp>
-        <p:nvSpPr>
-          <p:cNvPr id="3" name="슬라이드 번호 개체 틀 2"/>
+            <a:endParaRPr lang="ko-KR" altLang="en-US" dirty="0"/>
+          </a:p>
+        </p:txBody>
+      </p:sp>
+      <p:sp>
+        <p:nvSpPr>
+          <p:cNvPr id="5" name="슬라이드 번호 개체 틀 4">
+            <a:extLst>
+              <a:ext uri="{FF2B5EF4-FFF2-40B4-BE49-F238E27FC236}">
+                <a16:creationId xmlns:a16="http://schemas.microsoft.com/office/drawing/2014/main" id="{E038AD2A-D098-5002-7259-7C0CF8DAB853}"/>
+              </a:ext>
+            </a:extLst>
+          </p:cNvPr>
           <p:cNvSpPr>
             <a:spLocks noGrp="1"/>
           </p:cNvSpPr>
@@ -6378,13 +6419,19 @@
               <a:rPr lang="ko-KR" altLang="en-US" smtClean="0"/>
               <a:t>12</a:t>
             </a:fld>
-            <a:endParaRPr lang="ko-KR" altLang="en-US"/>
-          </a:p>
-        </p:txBody>
-      </p:sp>
-      <p:sp>
-        <p:nvSpPr>
-          <p:cNvPr id="4" name="제목 3"/>
+            <a:endParaRPr lang="ko-KR" altLang="en-US" dirty="0"/>
+          </a:p>
+        </p:txBody>
+      </p:sp>
+      <p:sp>
+        <p:nvSpPr>
+          <p:cNvPr id="2" name="제목 1">
+            <a:extLst>
+              <a:ext uri="{FF2B5EF4-FFF2-40B4-BE49-F238E27FC236}">
+                <a16:creationId xmlns:a16="http://schemas.microsoft.com/office/drawing/2014/main" id="{45FB17D5-C686-6D90-A10C-DFBDB6D2FE1F}"/>
+              </a:ext>
+            </a:extLst>
+          </p:cNvPr>
           <p:cNvSpPr>
             <a:spLocks noGrp="1"/>
           </p:cNvSpPr>
@@ -6398,25 +6445,20 @@
           <a:lstStyle/>
           <a:p>
             <a:r>
-              <a:rPr lang="en-US" altLang="ko-KR" sz="7200" dirty="0"/>
+              <a:rPr lang="en-US" altLang="ko-KR" dirty="0"/>
               <a:t>filter()</a:t>
             </a:r>
             <a:r>
-              <a:rPr lang="ko-KR" altLang="en-US" sz="7200" dirty="0"/>
-              <a:t>를 이용한 </a:t>
-            </a:r>
-            <a:r>
-              <a:rPr lang="ko-KR" altLang="en-US" sz="7200" dirty="0" err="1"/>
-              <a:t>필터링</a:t>
-            </a:r>
-            <a:endParaRPr lang="ko-KR" altLang="en-US" sz="7200" dirty="0"/>
+              <a:rPr lang="ko-KR" altLang="en-US" dirty="0"/>
+              <a:t> 함수</a:t>
+            </a:r>
           </a:p>
         </p:txBody>
       </p:sp>
     </p:spTree>
     <p:extLst>
       <p:ext uri="{BB962C8B-B14F-4D97-AF65-F5344CB8AC3E}">
-        <p14:creationId xmlns:p14="http://schemas.microsoft.com/office/powerpoint/2010/main" val="960713128"/>
+        <p14:creationId xmlns:p14="http://schemas.microsoft.com/office/powerpoint/2010/main" val="1354429162"/>
       </p:ext>
     </p:extLst>
   </p:cSld>
@@ -6445,240 +6487,6 @@
       </p:grpSpPr>
       <p:sp>
         <p:nvSpPr>
-          <p:cNvPr id="3" name="내용 개체 틀 2">
-            <a:extLst>
-              <a:ext uri="{FF2B5EF4-FFF2-40B4-BE49-F238E27FC236}">
-                <a16:creationId xmlns:a16="http://schemas.microsoft.com/office/drawing/2014/main" id="{FFB0A8FF-58B4-AADA-C277-115F024B2E5A}"/>
-              </a:ext>
-            </a:extLst>
-          </p:cNvPr>
-          <p:cNvSpPr>
-            <a:spLocks noGrp="1"/>
-          </p:cNvSpPr>
-          <p:nvPr>
-            <p:ph idx="1"/>
-          </p:nvPr>
-        </p:nvSpPr>
-        <p:spPr>
-          <a:xfrm>
-            <a:off x="571500" y="1488141"/>
-            <a:ext cx="11049000" cy="4553128"/>
-          </a:xfrm>
-        </p:spPr>
-        <p:txBody>
-          <a:bodyPr/>
-          <a:lstStyle/>
-          <a:p>
-            <a:r>
-              <a:rPr lang="en-US" altLang="ko-KR" dirty="0"/>
-              <a:t>filter()</a:t>
-            </a:r>
-            <a:r>
-              <a:rPr lang="ko-KR" altLang="en-US" dirty="0"/>
-              <a:t>의 인자로 넘겨지는 </a:t>
-            </a:r>
-            <a:r>
-              <a:rPr lang="en-US" altLang="ko-KR" dirty="0"/>
-              <a:t>callback </a:t>
-            </a:r>
-            <a:r>
-              <a:rPr lang="ko-KR" altLang="en-US" dirty="0"/>
-              <a:t>함수의 </a:t>
-            </a:r>
-            <a:r>
-              <a:rPr lang="ko-KR" altLang="en-US" dirty="0">
-                <a:solidFill>
-                  <a:schemeClr val="accent1"/>
-                </a:solidFill>
-              </a:rPr>
-              <a:t>테스트</a:t>
-            </a:r>
-            <a:r>
-              <a:rPr lang="en-US" altLang="ko-KR" dirty="0">
-                <a:solidFill>
-                  <a:schemeClr val="accent1"/>
-                </a:solidFill>
-              </a:rPr>
-              <a:t>(</a:t>
-            </a:r>
-            <a:r>
-              <a:rPr lang="ko-KR" altLang="en-US" dirty="0">
-                <a:solidFill>
-                  <a:schemeClr val="accent1"/>
-                </a:solidFill>
-              </a:rPr>
-              <a:t>조건</a:t>
-            </a:r>
-            <a:r>
-              <a:rPr lang="en-US" altLang="ko-KR" dirty="0">
-                <a:solidFill>
-                  <a:schemeClr val="accent1"/>
-                </a:solidFill>
-              </a:rPr>
-              <a:t>)</a:t>
-            </a:r>
-            <a:r>
-              <a:rPr lang="ko-KR" altLang="en-US" dirty="0">
-                <a:solidFill>
-                  <a:schemeClr val="accent1"/>
-                </a:solidFill>
-              </a:rPr>
-              <a:t>를 통과하는 요소</a:t>
-            </a:r>
-            <a:r>
-              <a:rPr lang="ko-KR" altLang="en-US" dirty="0"/>
-              <a:t>를 모아 새로운 배열을 생성</a:t>
-            </a:r>
-            <a:r>
-              <a:rPr lang="en-US" altLang="ko-KR" dirty="0"/>
-              <a:t>. </a:t>
-            </a:r>
-          </a:p>
-          <a:p>
-            <a:r>
-              <a:rPr lang="en-US" altLang="ko-KR" dirty="0"/>
-              <a:t>filter() </a:t>
-            </a:r>
-            <a:r>
-              <a:rPr lang="ko-KR" altLang="en-US" dirty="0"/>
-              <a:t>함수를 사용하여 배열에서 원하는 값을 삭제하는 코드 구현 가능</a:t>
-            </a:r>
-            <a:r>
-              <a:rPr lang="en-US" altLang="ko-KR" dirty="0"/>
-              <a:t>.</a:t>
-            </a:r>
-            <a:endParaRPr lang="en-US" altLang="ko-KR" sz="4000" dirty="0"/>
-          </a:p>
-          <a:p>
-            <a:pPr marL="0" indent="0">
-              <a:buNone/>
-            </a:pPr>
-            <a:endParaRPr lang="en-US" altLang="ko-KR" sz="4000" dirty="0"/>
-          </a:p>
-        </p:txBody>
-      </p:sp>
-      <p:sp>
-        <p:nvSpPr>
-          <p:cNvPr id="4" name="날짜 개체 틀 3">
-            <a:extLst>
-              <a:ext uri="{FF2B5EF4-FFF2-40B4-BE49-F238E27FC236}">
-                <a16:creationId xmlns:a16="http://schemas.microsoft.com/office/drawing/2014/main" id="{AD912659-0178-7724-84E7-F9804EEB516A}"/>
-              </a:ext>
-            </a:extLst>
-          </p:cNvPr>
-          <p:cNvSpPr>
-            <a:spLocks noGrp="1"/>
-          </p:cNvSpPr>
-          <p:nvPr>
-            <p:ph type="dt" sz="half" idx="10"/>
-          </p:nvPr>
-        </p:nvSpPr>
-        <p:spPr/>
-        <p:txBody>
-          <a:bodyPr/>
-          <a:lstStyle/>
-          <a:p>
-            <a:fld id="{ECE2EEAA-2D64-41F3-9CC6-1D2C9158BEA1}" type="datetime6">
-              <a:rPr lang="ko-KR" altLang="en-US" smtClean="0"/>
-              <a:t>2024년 8월</a:t>
-            </a:fld>
-            <a:endParaRPr lang="ko-KR" altLang="en-US" dirty="0"/>
-          </a:p>
-        </p:txBody>
-      </p:sp>
-      <p:sp>
-        <p:nvSpPr>
-          <p:cNvPr id="5" name="슬라이드 번호 개체 틀 4">
-            <a:extLst>
-              <a:ext uri="{FF2B5EF4-FFF2-40B4-BE49-F238E27FC236}">
-                <a16:creationId xmlns:a16="http://schemas.microsoft.com/office/drawing/2014/main" id="{E038AD2A-D098-5002-7259-7C0CF8DAB853}"/>
-              </a:ext>
-            </a:extLst>
-          </p:cNvPr>
-          <p:cNvSpPr>
-            <a:spLocks noGrp="1"/>
-          </p:cNvSpPr>
-          <p:nvPr>
-            <p:ph type="sldNum" sz="quarter" idx="12"/>
-          </p:nvPr>
-        </p:nvSpPr>
-        <p:spPr/>
-        <p:txBody>
-          <a:bodyPr/>
-          <a:lstStyle/>
-          <a:p>
-            <a:fld id="{083A2CE0-18CD-4102-B738-4ACFF9E68BA4}" type="slidenum">
-              <a:rPr lang="ko-KR" altLang="en-US" smtClean="0"/>
-              <a:t>13</a:t>
-            </a:fld>
-            <a:endParaRPr lang="ko-KR" altLang="en-US" dirty="0"/>
-          </a:p>
-        </p:txBody>
-      </p:sp>
-      <p:sp>
-        <p:nvSpPr>
-          <p:cNvPr id="2" name="제목 1">
-            <a:extLst>
-              <a:ext uri="{FF2B5EF4-FFF2-40B4-BE49-F238E27FC236}">
-                <a16:creationId xmlns:a16="http://schemas.microsoft.com/office/drawing/2014/main" id="{45FB17D5-C686-6D90-A10C-DFBDB6D2FE1F}"/>
-              </a:ext>
-            </a:extLst>
-          </p:cNvPr>
-          <p:cNvSpPr>
-            <a:spLocks noGrp="1"/>
-          </p:cNvSpPr>
-          <p:nvPr>
-            <p:ph type="title"/>
-          </p:nvPr>
-        </p:nvSpPr>
-        <p:spPr/>
-        <p:txBody>
-          <a:bodyPr/>
-          <a:lstStyle/>
-          <a:p>
-            <a:r>
-              <a:rPr lang="en-US" altLang="ko-KR" dirty="0"/>
-              <a:t>filter()</a:t>
-            </a:r>
-            <a:r>
-              <a:rPr lang="ko-KR" altLang="en-US" dirty="0"/>
-              <a:t> 함수</a:t>
-            </a:r>
-          </a:p>
-        </p:txBody>
-      </p:sp>
-    </p:spTree>
-    <p:extLst>
-      <p:ext uri="{BB962C8B-B14F-4D97-AF65-F5344CB8AC3E}">
-        <p14:creationId xmlns:p14="http://schemas.microsoft.com/office/powerpoint/2010/main" val="1354429162"/>
-      </p:ext>
-    </p:extLst>
-  </p:cSld>
-  <p:clrMapOvr>
-    <a:masterClrMapping/>
-  </p:clrMapOvr>
-</p:sld>
-</file>
-
-<file path=ppt/slides/slide14.xml><?xml version="1.0" encoding="utf-8"?>
-<p:sld xmlns:a="http://schemas.openxmlformats.org/drawingml/2006/main" xmlns:r="http://schemas.openxmlformats.org/officeDocument/2006/relationships" xmlns:p="http://schemas.openxmlformats.org/presentationml/2006/main">
-  <p:cSld>
-    <p:spTree>
-      <p:nvGrpSpPr>
-        <p:cNvPr id="1" name=""/>
-        <p:cNvGrpSpPr/>
-        <p:nvPr/>
-      </p:nvGrpSpPr>
-      <p:grpSpPr>
-        <a:xfrm>
-          <a:off x="0" y="0"/>
-          <a:ext cx="0" cy="0"/>
-          <a:chOff x="0" y="0"/>
-          <a:chExt cx="0" cy="0"/>
-        </a:xfrm>
-      </p:grpSpPr>
-      <p:sp>
-        <p:nvSpPr>
           <p:cNvPr id="4" name="날짜 개체 틀 3">
             <a:extLst>
               <a:ext uri="{FF2B5EF4-FFF2-40B4-BE49-F238E27FC236}">
@@ -6729,7 +6537,7 @@
           <a:p>
             <a:fld id="{083A2CE0-18CD-4102-B738-4ACFF9E68BA4}" type="slidenum">
               <a:rPr lang="ko-KR" altLang="en-US" smtClean="0"/>
-              <a:t>14</a:t>
+              <a:t>13</a:t>
             </a:fld>
             <a:endParaRPr lang="ko-KR" altLang="en-US"/>
           </a:p>
@@ -6870,7 +6678,7 @@
 </p:sld>
 </file>
 
-<file path=ppt/slides/slide15.xml><?xml version="1.0" encoding="utf-8"?>
+<file path=ppt/slides/slide14.xml><?xml version="1.0" encoding="utf-8"?>
 <p:sld xmlns:a="http://schemas.openxmlformats.org/drawingml/2006/main" xmlns:r="http://schemas.openxmlformats.org/officeDocument/2006/relationships" xmlns:p="http://schemas.openxmlformats.org/presentationml/2006/main">
   <p:cSld>
     <p:spTree>
@@ -6939,7 +6747,7 @@
           <a:p>
             <a:fld id="{083A2CE0-18CD-4102-B738-4ACFF9E68BA4}" type="slidenum">
               <a:rPr lang="ko-KR" altLang="en-US" smtClean="0"/>
-              <a:t>15</a:t>
+              <a:t>14</a:t>
             </a:fld>
             <a:endParaRPr lang="ko-KR" altLang="en-US"/>
           </a:p>
@@ -7020,7 +6828,7 @@
 </p:sld>
 </file>
 
-<file path=ppt/slides/slide16.xml><?xml version="1.0" encoding="utf-8"?>
+<file path=ppt/slides/slide15.xml><?xml version="1.0" encoding="utf-8"?>
 <p:sld xmlns:a="http://schemas.openxmlformats.org/drawingml/2006/main" xmlns:r="http://schemas.openxmlformats.org/officeDocument/2006/relationships" xmlns:p="http://schemas.openxmlformats.org/presentationml/2006/main">
   <p:cSld>
     <p:spTree>
@@ -7122,7 +6930,7 @@
           <a:p>
             <a:fld id="{083A2CE0-18CD-4102-B738-4ACFF9E68BA4}" type="slidenum">
               <a:rPr lang="ko-KR" altLang="en-US" smtClean="0"/>
-              <a:t>16</a:t>
+              <a:t>15</a:t>
             </a:fld>
             <a:endParaRPr lang="ko-KR" altLang="en-US"/>
           </a:p>
@@ -7345,7 +7153,7 @@
 </p:sld>
 </file>
 
-<file path=ppt/slides/slide17.xml><?xml version="1.0" encoding="utf-8"?>
+<file path=ppt/slides/slide16.xml><?xml version="1.0" encoding="utf-8"?>
 <p:sld xmlns:a="http://schemas.openxmlformats.org/drawingml/2006/main" xmlns:r="http://schemas.openxmlformats.org/officeDocument/2006/relationships" xmlns:p="http://schemas.openxmlformats.org/presentationml/2006/main">
   <p:cSld>
     <p:spTree>
@@ -7364,260 +7172,6 @@
       </p:grpSpPr>
       <p:sp>
         <p:nvSpPr>
-          <p:cNvPr id="4" name="날짜 개체 틀 3">
-            <a:extLst>
-              <a:ext uri="{FF2B5EF4-FFF2-40B4-BE49-F238E27FC236}">
-                <a16:creationId xmlns:a16="http://schemas.microsoft.com/office/drawing/2014/main" id="{8F058E69-2519-5C7B-E619-FCE4F8E785F7}"/>
-              </a:ext>
-            </a:extLst>
-          </p:cNvPr>
-          <p:cNvSpPr>
-            <a:spLocks noGrp="1"/>
-          </p:cNvSpPr>
-          <p:nvPr>
-            <p:ph type="dt" sz="half" idx="10"/>
-          </p:nvPr>
-        </p:nvSpPr>
-        <p:spPr/>
-        <p:txBody>
-          <a:bodyPr/>
-          <a:lstStyle/>
-          <a:p>
-            <a:fld id="{499F60AA-9663-4C10-96A7-DFE487A1DFF7}" type="datetime6">
-              <a:rPr lang="ko-KR" altLang="en-US" smtClean="0"/>
-              <a:t>2024년 8월</a:t>
-            </a:fld>
-            <a:endParaRPr lang="ko-KR" altLang="en-US"/>
-          </a:p>
-        </p:txBody>
-      </p:sp>
-      <p:sp>
-        <p:nvSpPr>
-          <p:cNvPr id="5" name="슬라이드 번호 개체 틀 4">
-            <a:extLst>
-              <a:ext uri="{FF2B5EF4-FFF2-40B4-BE49-F238E27FC236}">
-                <a16:creationId xmlns:a16="http://schemas.microsoft.com/office/drawing/2014/main" id="{4A2D925E-B075-9DDE-125B-43171B9E6A97}"/>
-              </a:ext>
-            </a:extLst>
-          </p:cNvPr>
-          <p:cNvSpPr>
-            <a:spLocks noGrp="1"/>
-          </p:cNvSpPr>
-          <p:nvPr>
-            <p:ph type="sldNum" sz="quarter" idx="12"/>
-          </p:nvPr>
-        </p:nvSpPr>
-        <p:spPr/>
-        <p:txBody>
-          <a:bodyPr/>
-          <a:lstStyle/>
-          <a:p>
-            <a:fld id="{083A2CE0-18CD-4102-B738-4ACFF9E68BA4}" type="slidenum">
-              <a:rPr lang="ko-KR" altLang="en-US" smtClean="0"/>
-              <a:t>17</a:t>
-            </a:fld>
-            <a:endParaRPr lang="ko-KR" altLang="en-US"/>
-          </a:p>
-        </p:txBody>
-      </p:sp>
-      <p:sp>
-        <p:nvSpPr>
-          <p:cNvPr id="2" name="제목 1">
-            <a:extLst>
-              <a:ext uri="{FF2B5EF4-FFF2-40B4-BE49-F238E27FC236}">
-                <a16:creationId xmlns:a16="http://schemas.microsoft.com/office/drawing/2014/main" id="{DEEAE432-154C-1C3F-A5EC-16DFF73F5EC7}"/>
-              </a:ext>
-            </a:extLst>
-          </p:cNvPr>
-          <p:cNvSpPr>
-            <a:spLocks noGrp="1"/>
-          </p:cNvSpPr>
-          <p:nvPr>
-            <p:ph type="title"/>
-          </p:nvPr>
-        </p:nvSpPr>
-        <p:spPr/>
-        <p:txBody>
-          <a:bodyPr/>
-          <a:lstStyle/>
-          <a:p>
-            <a:r>
-              <a:rPr lang="en-US" altLang="ko-KR" dirty="0"/>
-              <a:t>filter() </a:t>
-            </a:r>
-            <a:r>
-              <a:rPr lang="ko-KR" altLang="en-US" dirty="0"/>
-              <a:t>응용</a:t>
-            </a:r>
-          </a:p>
-        </p:txBody>
-      </p:sp>
-      <p:pic>
-        <p:nvPicPr>
-          <p:cNvPr id="10" name="그림 9">
-            <a:extLst>
-              <a:ext uri="{FF2B5EF4-FFF2-40B4-BE49-F238E27FC236}">
-                <a16:creationId xmlns:a16="http://schemas.microsoft.com/office/drawing/2014/main" id="{FC0EB19B-C0C6-4EE2-71CC-D431A634BFE3}"/>
-              </a:ext>
-            </a:extLst>
-          </p:cNvPr>
-          <p:cNvPicPr>
-            <a:picLocks noChangeAspect="1"/>
-          </p:cNvPicPr>
-          <p:nvPr/>
-        </p:nvPicPr>
-        <p:blipFill>
-          <a:blip r:embed="rId3"/>
-          <a:stretch>
-            <a:fillRect/>
-          </a:stretch>
-        </p:blipFill>
-        <p:spPr>
-          <a:xfrm>
-            <a:off x="586613" y="1214051"/>
-            <a:ext cx="11018774" cy="4787183"/>
-          </a:xfrm>
-          <a:prstGeom prst="rect">
-            <a:avLst/>
-          </a:prstGeom>
-        </p:spPr>
-      </p:pic>
-      <p:sp>
-        <p:nvSpPr>
-          <p:cNvPr id="13" name="직사각형 12">
-            <a:extLst>
-              <a:ext uri="{FF2B5EF4-FFF2-40B4-BE49-F238E27FC236}">
-                <a16:creationId xmlns:a16="http://schemas.microsoft.com/office/drawing/2014/main" id="{2E775F9E-EA2C-FD91-9B4F-4BA95A07505D}"/>
-              </a:ext>
-            </a:extLst>
-          </p:cNvPr>
-          <p:cNvSpPr/>
-          <p:nvPr/>
-        </p:nvSpPr>
-        <p:spPr>
-          <a:xfrm>
-            <a:off x="635620" y="2587083"/>
-            <a:ext cx="6322741" cy="1115122"/>
-          </a:xfrm>
-          <a:prstGeom prst="rect">
-            <a:avLst/>
-          </a:prstGeom>
-          <a:noFill/>
-          <a:ln w="38100">
-            <a:solidFill>
-              <a:schemeClr val="accent5"/>
-            </a:solidFill>
-          </a:ln>
-        </p:spPr>
-        <p:style>
-          <a:lnRef idx="2">
-            <a:schemeClr val="accent1">
-              <a:shade val="50000"/>
-            </a:schemeClr>
-          </a:lnRef>
-          <a:fillRef idx="1">
-            <a:schemeClr val="accent1"/>
-          </a:fillRef>
-          <a:effectRef idx="0">
-            <a:schemeClr val="accent1"/>
-          </a:effectRef>
-          <a:fontRef idx="minor">
-            <a:schemeClr val="lt1"/>
-          </a:fontRef>
-        </p:style>
-        <p:txBody>
-          <a:bodyPr rtlCol="0" anchor="ctr"/>
-          <a:lstStyle/>
-          <a:p>
-            <a:pPr algn="ctr"/>
-            <a:endParaRPr lang="ko-KR" altLang="en-US" dirty="0"/>
-          </a:p>
-        </p:txBody>
-      </p:sp>
-      <p:sp>
-        <p:nvSpPr>
-          <p:cNvPr id="16" name="직사각형 15">
-            <a:extLst>
-              <a:ext uri="{FF2B5EF4-FFF2-40B4-BE49-F238E27FC236}">
-                <a16:creationId xmlns:a16="http://schemas.microsoft.com/office/drawing/2014/main" id="{DA0AC4FB-083D-982A-0BE5-18B0ED76F017}"/>
-              </a:ext>
-            </a:extLst>
-          </p:cNvPr>
-          <p:cNvSpPr/>
-          <p:nvPr/>
-        </p:nvSpPr>
-        <p:spPr>
-          <a:xfrm>
-            <a:off x="5207621" y="4916257"/>
-            <a:ext cx="4241180" cy="347120"/>
-          </a:xfrm>
-          <a:prstGeom prst="rect">
-            <a:avLst/>
-          </a:prstGeom>
-          <a:noFill/>
-          <a:ln w="38100">
-            <a:solidFill>
-              <a:schemeClr val="accent5"/>
-            </a:solidFill>
-          </a:ln>
-        </p:spPr>
-        <p:style>
-          <a:lnRef idx="2">
-            <a:schemeClr val="accent1">
-              <a:shade val="50000"/>
-            </a:schemeClr>
-          </a:lnRef>
-          <a:fillRef idx="1">
-            <a:schemeClr val="accent1"/>
-          </a:fillRef>
-          <a:effectRef idx="0">
-            <a:schemeClr val="accent1"/>
-          </a:effectRef>
-          <a:fontRef idx="minor">
-            <a:schemeClr val="lt1"/>
-          </a:fontRef>
-        </p:style>
-        <p:txBody>
-          <a:bodyPr rtlCol="0" anchor="ctr"/>
-          <a:lstStyle/>
-          <a:p>
-            <a:pPr algn="ctr"/>
-            <a:endParaRPr lang="ko-KR" altLang="en-US" dirty="0"/>
-          </a:p>
-        </p:txBody>
-      </p:sp>
-    </p:spTree>
-    <p:extLst>
-      <p:ext uri="{BB962C8B-B14F-4D97-AF65-F5344CB8AC3E}">
-        <p14:creationId xmlns:p14="http://schemas.microsoft.com/office/powerpoint/2010/main" val="2495203983"/>
-      </p:ext>
-    </p:extLst>
-  </p:cSld>
-  <p:clrMapOvr>
-    <a:masterClrMapping/>
-  </p:clrMapOvr>
-</p:sld>
-</file>
-
-<file path=ppt/slides/slide18.xml><?xml version="1.0" encoding="utf-8"?>
-<p:sld xmlns:a="http://schemas.openxmlformats.org/drawingml/2006/main" xmlns:r="http://schemas.openxmlformats.org/officeDocument/2006/relationships" xmlns:p="http://schemas.openxmlformats.org/presentationml/2006/main">
-  <p:cSld>
-    <p:spTree>
-      <p:nvGrpSpPr>
-        <p:cNvPr id="1" name=""/>
-        <p:cNvGrpSpPr/>
-        <p:nvPr/>
-      </p:nvGrpSpPr>
-      <p:grpSpPr>
-        <a:xfrm>
-          <a:off x="0" y="0"/>
-          <a:ext cx="0" cy="0"/>
-          <a:chOff x="0" y="0"/>
-          <a:chExt cx="0" cy="0"/>
-        </a:xfrm>
-      </p:grpSpPr>
-      <p:sp>
-        <p:nvSpPr>
           <p:cNvPr id="13" name="내용 개체 틀 2">
             <a:extLst>
               <a:ext uri="{FF2B5EF4-FFF2-40B4-BE49-F238E27FC236}">
@@ -7680,7 +7234,7 @@
           <a:p>
             <a:fld id="{0F78D9C4-20C1-4B15-A116-16DC77AD9A1E}" type="datetime1">
               <a:rPr lang="ko-KR" altLang="en-US" smtClean="0"/>
-              <a:t>2024-08-05</a:t>
+              <a:t>2024-08-06</a:t>
             </a:fld>
             <a:endParaRPr lang="ko-KR" altLang="en-US"/>
           </a:p>
@@ -7709,7 +7263,7 @@
           <a:p>
             <a:fld id="{083A2CE0-18CD-4102-B738-4ACFF9E68BA4}" type="slidenum">
               <a:rPr lang="ko-KR" altLang="en-US" smtClean="0"/>
-              <a:t>18</a:t>
+              <a:t>16</a:t>
             </a:fld>
             <a:endParaRPr lang="ko-KR" altLang="en-US"/>
           </a:p>

</xml_diff>